<commit_message>
adding raw data and updating obsidian
</commit_message>
<xml_diff>
--- a/presentation/Measuring-TD-in-Trading-Systems-Thesis-Defence.pptx
+++ b/presentation/Measuring-TD-in-Trading-Systems-Thesis-Defence.pptx
@@ -211,7 +211,7 @@
           <a:p>
             <a:fld id="{3E21E6FB-D8FF-314A-9117-E719EF5E90D5}" type="datetimeFigureOut">
               <a:rPr lang="en-CH" smtClean="0"/>
-              <a:t>12.08.2026</a:t>
+              <a:t>16.08.2026</a:t>
             </a:fld>
             <a:endParaRPr lang="en-CH"/>
           </a:p>
@@ -1870,7 +1870,7 @@
           <a:p>
             <a:fld id="{AEDE047E-B4B0-4DE8-B14D-9A9166827141}" type="datetime1">
               <a:rPr lang="de-CH" smtClean="0"/>
-              <a:t>12.08.26</a:t>
+              <a:t>16.08.26</a:t>
             </a:fld>
             <a:endParaRPr lang="de-CH" sz="1000" dirty="0"/>
           </a:p>
@@ -2143,7 +2143,7 @@
           <a:p>
             <a:fld id="{99546A82-6786-4BEF-A005-07B9FB01AD1F}" type="datetime1">
               <a:rPr lang="de-CH" smtClean="0"/>
-              <a:t>12.08.26</a:t>
+              <a:t>16.08.26</a:t>
             </a:fld>
             <a:endParaRPr lang="de-CH" sz="1000" dirty="0"/>
           </a:p>
@@ -2696,7 +2696,7 @@
                 <a:cs typeface="Calibri" panose="020F0502020204030204" pitchFamily="34" charset="0"/>
               </a:rPr>
               <a:pPr/>
-              <a:t>12 August, 2026</a:t>
+              <a:t>16 August, 2026</a:t>
             </a:fld>
             <a:endParaRPr lang="en-US" dirty="0">
               <a:solidFill>
@@ -2784,7 +2784,7 @@
           <a:p>
             <a:fld id="{0F9AB8A7-31A5-4BA1-8C6C-847B0F38C877}" type="datetime1">
               <a:rPr lang="de-CH" smtClean="0"/>
-              <a:t>12.08.26</a:t>
+              <a:t>16.08.26</a:t>
             </a:fld>
             <a:endParaRPr lang="de-CH" sz="1000" dirty="0"/>
           </a:p>
@@ -3057,7 +3057,7 @@
           <a:p>
             <a:fld id="{09211416-94C2-4FA3-8BB3-C473D4632185}" type="datetime1">
               <a:rPr lang="de-CH" smtClean="0"/>
-              <a:t>12.08.26</a:t>
+              <a:t>16.08.26</a:t>
             </a:fld>
             <a:endParaRPr lang="de-CH" sz="1000" dirty="0"/>
           </a:p>
@@ -3406,7 +3406,7 @@
           <a:p>
             <a:fld id="{8D8B043F-955F-44BD-935B-3E632ED9A93A}" type="datetime1">
               <a:rPr lang="de-CH" smtClean="0"/>
-              <a:t>12.08.26</a:t>
+              <a:t>16.08.26</a:t>
             </a:fld>
             <a:endParaRPr lang="de-CH" sz="1000" dirty="0"/>
           </a:p>
@@ -3747,7 +3747,7 @@
           <a:p>
             <a:fld id="{8A55FDCF-5EE4-4878-AB91-E8AC89F79CE3}" type="datetime1">
               <a:rPr lang="de-CH" smtClean="0"/>
-              <a:t>12.08.26</a:t>
+              <a:t>16.08.26</a:t>
             </a:fld>
             <a:endParaRPr lang="de-CH" sz="1000" dirty="0"/>
           </a:p>
@@ -4235,7 +4235,7 @@
           <a:p>
             <a:fld id="{706FAE65-C4FA-4A43-BE8F-264B1224F450}" type="datetime1">
               <a:rPr lang="de-CH" smtClean="0"/>
-              <a:t>12.08.26</a:t>
+              <a:t>16.08.26</a:t>
             </a:fld>
             <a:endParaRPr lang="de-CH" sz="1000" dirty="0"/>
           </a:p>
@@ -4450,7 +4450,7 @@
           <a:p>
             <a:fld id="{11388C40-3466-4698-A524-3A340549EAD7}" type="datetime1">
               <a:rPr lang="de-CH" smtClean="0"/>
-              <a:t>12.08.26</a:t>
+              <a:t>16.08.26</a:t>
             </a:fld>
             <a:endParaRPr lang="de-CH" sz="1000" dirty="0"/>
           </a:p>
@@ -4636,7 +4636,7 @@
           <a:p>
             <a:fld id="{299CCFBB-BDBD-4A89-80F9-DCD36CF51D83}" type="datetime1">
               <a:rPr lang="de-CH" smtClean="0"/>
-              <a:t>12.08.26</a:t>
+              <a:t>16.08.26</a:t>
             </a:fld>
             <a:endParaRPr lang="de-CH" sz="1000" dirty="0"/>
           </a:p>
@@ -5022,7 +5022,7 @@
           <a:p>
             <a:fld id="{C65EF651-C1E2-413C-9502-50791E906517}" type="datetime1">
               <a:rPr lang="de-CH" smtClean="0"/>
-              <a:t>12.08.26</a:t>
+              <a:t>16.08.26</a:t>
             </a:fld>
             <a:endParaRPr lang="de-CH" sz="1000" dirty="0"/>
           </a:p>
@@ -5384,7 +5384,7 @@
           <a:p>
             <a:fld id="{B0BB0A37-77CD-424F-A2E6-692D2E264308}" type="datetime1">
               <a:rPr lang="de-CH" smtClean="0"/>
-              <a:t>12.08.26</a:t>
+              <a:t>16.08.26</a:t>
             </a:fld>
             <a:endParaRPr lang="de-CH" sz="1000" dirty="0"/>
           </a:p>
@@ -5682,7 +5682,7 @@
           <a:p>
             <a:fld id="{2D36D260-0F21-449E-B98E-B5097AE48E3F}" type="datetime1">
               <a:rPr lang="de-CH" smtClean="0"/>
-              <a:t>12.08.26</a:t>
+              <a:t>16.08.26</a:t>
             </a:fld>
             <a:endParaRPr lang="de-CH" sz="1000" dirty="0"/>
           </a:p>
@@ -22233,8 +22233,8 @@
           </a:p>
         </p:txBody>
       </p:sp>
-      <mc:AlternateContent xmlns:mc="http://schemas.openxmlformats.org/markup-compatibility/2006">
-        <mc:Choice xmlns:a14="http://schemas.microsoft.com/office/drawing/2010/main" Requires="a14">
+      <mc:AlternateContent xmlns:mc="http://schemas.openxmlformats.org/markup-compatibility/2006" xmlns:a14="http://schemas.microsoft.com/office/drawing/2010/main">
+        <mc:Choice Requires="a14">
           <p:sp>
             <p:nvSpPr>
               <p:cNvPr id="8" name="Text 6"/>
@@ -22304,7 +22304,7 @@
             </p:txBody>
           </p:sp>
         </mc:Choice>
-        <mc:Fallback>
+        <mc:Fallback xmlns="">
           <p:sp>
             <p:nvSpPr>
               <p:cNvPr id="8" name="Text 6"/>
@@ -22446,8 +22446,8 @@
           </a:p>
         </p:txBody>
       </p:sp>
-      <mc:AlternateContent xmlns:mc="http://schemas.openxmlformats.org/markup-compatibility/2006">
-        <mc:Choice xmlns:a14="http://schemas.microsoft.com/office/drawing/2010/main" Requires="a14">
+      <mc:AlternateContent xmlns:mc="http://schemas.openxmlformats.org/markup-compatibility/2006" xmlns:a14="http://schemas.microsoft.com/office/drawing/2010/main">
+        <mc:Choice Requires="a14">
           <p:sp>
             <p:nvSpPr>
               <p:cNvPr id="12" name="Text 10"/>
@@ -22517,7 +22517,7 @@
             </p:txBody>
           </p:sp>
         </mc:Choice>
-        <mc:Fallback>
+        <mc:Fallback xmlns="">
           <p:sp>
             <p:nvSpPr>
               <p:cNvPr id="12" name="Text 10"/>
@@ -22659,8 +22659,8 @@
           </a:p>
         </p:txBody>
       </p:sp>
-      <mc:AlternateContent xmlns:mc="http://schemas.openxmlformats.org/markup-compatibility/2006">
-        <mc:Choice xmlns:a14="http://schemas.microsoft.com/office/drawing/2010/main" Requires="a14">
+      <mc:AlternateContent xmlns:mc="http://schemas.openxmlformats.org/markup-compatibility/2006" xmlns:a14="http://schemas.microsoft.com/office/drawing/2010/main">
+        <mc:Choice Requires="a14">
           <p:sp>
             <p:nvSpPr>
               <p:cNvPr id="16" name="Text 14"/>
@@ -22730,7 +22730,7 @@
             </p:txBody>
           </p:sp>
         </mc:Choice>
-        <mc:Fallback>
+        <mc:Fallback xmlns="">
           <p:sp>
             <p:nvSpPr>
               <p:cNvPr id="16" name="Text 14"/>

</xml_diff>

<commit_message>
minor fixes in the presentation
</commit_message>
<xml_diff>
--- a/presentation/Measuring-TD-in-Trading-Systems-Thesis-Defence.pptx
+++ b/presentation/Measuring-TD-in-Trading-Systems-Thesis-Defence.pptx
@@ -17759,7 +17759,7 @@
               <a:t>. </a:t>
             </a:r>
             <a:r>
-              <a:rPr lang="en-GB" sz="1400" noProof="0" dirty="0">
+              <a:rPr lang="en-GB" sz="1400" noProof="0" dirty="0" err="1">
                 <a:solidFill>
                   <a:srgbClr val="1A2540"/>
                 </a:solidFill>
@@ -17778,7 +17778,7 @@
                 <a:ea typeface="Calibri" pitchFamily="34" charset="-122"/>
                 <a:cs typeface="Calibri" pitchFamily="34" charset="-120"/>
               </a:rPr>
-              <a:t> + FINMA 2023/1; BCS Code of Conduct. Scores describe services, not teams.</a:t>
+              <a:t>; BCS Code of Conduct. Scores describe services, not teams.</a:t>
             </a:r>
             <a:endParaRPr lang="en-US" sz="1400" dirty="0"/>
           </a:p>

</xml_diff>

<commit_message>
minor fix on presentation
</commit_message>
<xml_diff>
--- a/presentation/Measuring-TD-in-Trading-Systems-Thesis-Defence.pptx
+++ b/presentation/Measuring-TD-in-Trading-Systems-Thesis-Defence.pptx
@@ -211,7 +211,7 @@
           <a:p>
             <a:fld id="{3E21E6FB-D8FF-314A-9117-E719EF5E90D5}" type="datetimeFigureOut">
               <a:rPr lang="en-CH" smtClean="0"/>
-              <a:t>16.08.2026</a:t>
+              <a:t>17.08.2026</a:t>
             </a:fld>
             <a:endParaRPr lang="en-CH"/>
           </a:p>
@@ -1870,7 +1870,7 @@
           <a:p>
             <a:fld id="{AEDE047E-B4B0-4DE8-B14D-9A9166827141}" type="datetime1">
               <a:rPr lang="de-CH" smtClean="0"/>
-              <a:t>16.08.26</a:t>
+              <a:t>17.08.26</a:t>
             </a:fld>
             <a:endParaRPr lang="de-CH" sz="1000" dirty="0"/>
           </a:p>
@@ -2143,7 +2143,7 @@
           <a:p>
             <a:fld id="{99546A82-6786-4BEF-A005-07B9FB01AD1F}" type="datetime1">
               <a:rPr lang="de-CH" smtClean="0"/>
-              <a:t>16.08.26</a:t>
+              <a:t>17.08.26</a:t>
             </a:fld>
             <a:endParaRPr lang="de-CH" sz="1000" dirty="0"/>
           </a:p>
@@ -2696,7 +2696,7 @@
                 <a:cs typeface="Calibri" panose="020F0502020204030204" pitchFamily="34" charset="0"/>
               </a:rPr>
               <a:pPr/>
-              <a:t>16 August, 2026</a:t>
+              <a:t>17 August, 2026</a:t>
             </a:fld>
             <a:endParaRPr lang="en-US" dirty="0">
               <a:solidFill>
@@ -2784,7 +2784,7 @@
           <a:p>
             <a:fld id="{0F9AB8A7-31A5-4BA1-8C6C-847B0F38C877}" type="datetime1">
               <a:rPr lang="de-CH" smtClean="0"/>
-              <a:t>16.08.26</a:t>
+              <a:t>17.08.26</a:t>
             </a:fld>
             <a:endParaRPr lang="de-CH" sz="1000" dirty="0"/>
           </a:p>
@@ -3057,7 +3057,7 @@
           <a:p>
             <a:fld id="{09211416-94C2-4FA3-8BB3-C473D4632185}" type="datetime1">
               <a:rPr lang="de-CH" smtClean="0"/>
-              <a:t>16.08.26</a:t>
+              <a:t>17.08.26</a:t>
             </a:fld>
             <a:endParaRPr lang="de-CH" sz="1000" dirty="0"/>
           </a:p>
@@ -3406,7 +3406,7 @@
           <a:p>
             <a:fld id="{8D8B043F-955F-44BD-935B-3E632ED9A93A}" type="datetime1">
               <a:rPr lang="de-CH" smtClean="0"/>
-              <a:t>16.08.26</a:t>
+              <a:t>17.08.26</a:t>
             </a:fld>
             <a:endParaRPr lang="de-CH" sz="1000" dirty="0"/>
           </a:p>
@@ -3747,7 +3747,7 @@
           <a:p>
             <a:fld id="{8A55FDCF-5EE4-4878-AB91-E8AC89F79CE3}" type="datetime1">
               <a:rPr lang="de-CH" smtClean="0"/>
-              <a:t>16.08.26</a:t>
+              <a:t>17.08.26</a:t>
             </a:fld>
             <a:endParaRPr lang="de-CH" sz="1000" dirty="0"/>
           </a:p>
@@ -4235,7 +4235,7 @@
           <a:p>
             <a:fld id="{706FAE65-C4FA-4A43-BE8F-264B1224F450}" type="datetime1">
               <a:rPr lang="de-CH" smtClean="0"/>
-              <a:t>16.08.26</a:t>
+              <a:t>17.08.26</a:t>
             </a:fld>
             <a:endParaRPr lang="de-CH" sz="1000" dirty="0"/>
           </a:p>
@@ -4450,7 +4450,7 @@
           <a:p>
             <a:fld id="{11388C40-3466-4698-A524-3A340549EAD7}" type="datetime1">
               <a:rPr lang="de-CH" smtClean="0"/>
-              <a:t>16.08.26</a:t>
+              <a:t>17.08.26</a:t>
             </a:fld>
             <a:endParaRPr lang="de-CH" sz="1000" dirty="0"/>
           </a:p>
@@ -4636,7 +4636,7 @@
           <a:p>
             <a:fld id="{299CCFBB-BDBD-4A89-80F9-DCD36CF51D83}" type="datetime1">
               <a:rPr lang="de-CH" smtClean="0"/>
-              <a:t>16.08.26</a:t>
+              <a:t>17.08.26</a:t>
             </a:fld>
             <a:endParaRPr lang="de-CH" sz="1000" dirty="0"/>
           </a:p>
@@ -5022,7 +5022,7 @@
           <a:p>
             <a:fld id="{C65EF651-C1E2-413C-9502-50791E906517}" type="datetime1">
               <a:rPr lang="de-CH" smtClean="0"/>
-              <a:t>16.08.26</a:t>
+              <a:t>17.08.26</a:t>
             </a:fld>
             <a:endParaRPr lang="de-CH" sz="1000" dirty="0"/>
           </a:p>
@@ -5384,7 +5384,7 @@
           <a:p>
             <a:fld id="{B0BB0A37-77CD-424F-A2E6-692D2E264308}" type="datetime1">
               <a:rPr lang="de-CH" smtClean="0"/>
-              <a:t>16.08.26</a:t>
+              <a:t>17.08.26</a:t>
             </a:fld>
             <a:endParaRPr lang="de-CH" sz="1000" dirty="0"/>
           </a:p>
@@ -5682,7 +5682,7 @@
           <a:p>
             <a:fld id="{2D36D260-0F21-449E-B98E-B5097AE48E3F}" type="datetime1">
               <a:rPr lang="de-CH" smtClean="0"/>
-              <a:t>16.08.26</a:t>
+              <a:t>17.08.26</a:t>
             </a:fld>
             <a:endParaRPr lang="de-CH" sz="1000" dirty="0"/>
           </a:p>
@@ -6526,7 +6526,7 @@
               </a:spcBef>
             </a:pPr>
             <a:r>
-              <a:rPr lang="en-US" sz="1200" dirty="0">
+              <a:rPr lang="en-US" sz="1200">
                 <a:solidFill>
                   <a:srgbClr val="CADCFC"/>
                 </a:solidFill>
@@ -6534,7 +6534,18 @@
                 <a:ea typeface="Calibri" panose="020F0502020204030204" pitchFamily="34" charset="0"/>
                 <a:cs typeface="Calibri" panose="020F0502020204030204" pitchFamily="34" charset="0"/>
               </a:rPr>
-              <a:t>13 August 2026</a:t>
+              <a:t>18 August </a:t>
+            </a:r>
+            <a:r>
+              <a:rPr lang="en-US" sz="1200" dirty="0">
+                <a:solidFill>
+                  <a:srgbClr val="CADCFC"/>
+                </a:solidFill>
+                <a:latin typeface="Calibri" panose="020F0502020204030204" pitchFamily="34" charset="0"/>
+                <a:ea typeface="Calibri" panose="020F0502020204030204" pitchFamily="34" charset="0"/>
+                <a:cs typeface="Calibri" panose="020F0502020204030204" pitchFamily="34" charset="0"/>
+              </a:rPr>
+              <a:t>2026</a:t>
             </a:r>
           </a:p>
         </p:txBody>

</xml_diff>